<commit_message>
Presentacion U2: arquitectura Lambda con sus tres capas
La diapositiva 4 muestra la capa batch, la de velocidad y la de servicio,
con la nota del orador para explicarlas.

Co-Authored-By: Claude Opus 5.5 <noreply@anthropic.com>
</commit_message>
<xml_diff>
--- a/docs/presentacion/CryptoPulse_U2.pptx
+++ b/docs/presentacion/CryptoPulse_U2.pptx
@@ -127,7 +127,7 @@
   <p:extLst>
     <p:ext uri="{521415D9-36F7-43E2-AB2F-B90AF26B5E84}">
       <p14:sectionLst xmlns:p14="http://schemas.microsoft.com/office/powerpoint/2010/main">
-        <p14:section name="Apertura · Luz Milagros" id="{858bee08-69c2-132d-f530-e45836e2fbde}">
+        <p14:section name="Apertura · Luz Milagros" id="{c73dc37a-d282-d3cd-9c3f-06c1d556f953}">
           <p14:sldIdLst>
             <p14:sldId id="256"/>
             <p14:sldId id="257"/>
@@ -135,7 +135,7 @@
             <p14:sldId id="259"/>
           </p14:sldIdLst>
         </p14:section>
-        <p14:section name="Ingesta y streaming · Julmer" id="{34fb967a-2b0a-088a-a780-455f0b8fb3ae}">
+        <p14:section name="Ingesta y streaming · Julmer" id="{dc912dd9-11c6-3c8a-e52c-fd9a57de09c7}">
           <p14:sldIdLst>
             <p14:sldId id="260"/>
             <p14:sldId id="261"/>
@@ -144,7 +144,7 @@
             <p14:sldId id="264"/>
           </p14:sldIdLst>
         </p14:section>
-        <p14:section name="Observabilidad y costos · Abdul" id="{69d773da-8844-29c6-2bdf-d0a45bc8e10c}">
+        <p14:section name="Observabilidad y costos · Abdul" id="{23a067e6-1a8b-66a8-2895-fd22c7db03fc}">
           <p14:sldIdLst>
             <p14:sldId id="265"/>
             <p14:sldId id="266"/>
@@ -152,14 +152,14 @@
             <p14:sldId id="268"/>
           </p14:sldIdLst>
         </p14:section>
-        <p14:section name="Inferencia · Franck" id="{c07ea43a-c047-181d-9426-b61cf88b21f4}">
+        <p14:section name="Inferencia · Franck" id="{ed5fd5e7-c0b4-234c-126d-d960d162d262}">
           <p14:sldIdLst>
             <p14:sldId id="269"/>
             <p14:sldId id="270"/>
             <p14:sldId id="271"/>
           </p14:sldIdLst>
         </p14:section>
-        <p14:section name="BI/ML e integración · Luz Milagros" id="{962737f1-96d5-782d-8e2c-0faea4c8b604}">
+        <p14:section name="BI/ML e integración · Luz Milagros" id="{13d2e62b-2871-7a1c-2497-95428287ea67}">
           <p14:sldIdLst>
             <p14:sldId id="272"/>
             <p14:sldId id="273"/>
@@ -2253,7 +2253,7 @@
           <a:p>
             <a:r>
               <a:rPr lang="en-US" dirty="0"/>
-              <a:t>Luz Milagros: recorre el flujo de izquierda a derecha y da paso a Julmer.</a:t>
+              <a:t>Luz Milagros: explica las tres capas Lambda. La capa batch aprende del histórico completo y entrena los modelos; la capa de velocidad aplica esos mismos modelos a cada vela en vivo con Kafka y Spark; la capa de servicio une ambas vistas en PostgreSQL y Grafana. Se eligió Lambda porque entrenar necesita todo el histórico y vigilar el riesgo necesita reaccionar en segundos. Da paso a Julmer.</a:t>
             </a:r>
             <a:endParaRPr lang="en-US" dirty="0"/>
           </a:p>
@@ -15475,7 +15475,7 @@
         <p:spPr>
           <a:xfrm>
             <a:off x="548640" y="347472"/>
-            <a:ext cx="1225296" cy="292608"/>
+            <a:ext cx="1833372" cy="292608"/>
           </a:xfrm>
           <a:prstGeom prst="roundRect">
             <a:avLst>
@@ -15499,7 +15499,7 @@
         <p:spPr>
           <a:xfrm>
             <a:off x="548640" y="347472"/>
-            <a:ext cx="1225296" cy="292608"/>
+            <a:ext cx="1833372" cy="292608"/>
           </a:xfrm>
           <a:prstGeom prst="rect">
             <a:avLst/>
@@ -15520,7 +15520,7 @@
                   <a:schemeClr val="accent2"/>
                 </a:solidFill>
               </a:rPr>
-              <a:t>ARQUITECTURA</a:t>
+              <a:t>ARQUITECTURA LAMBDA</a:t>
             </a:r>
             <a:endParaRPr lang="en-US" sz="1050" dirty="0"/>
           </a:p>
@@ -15625,7 +15625,7 @@
                   <a:schemeClr val="tx2"/>
                 </a:solidFill>
               </a:rPr>
-              <a:t>Un solo pipeline, de la fuente al tablero</a:t>
+              <a:t>Arquitectura Lambda: aprende del pasado, actúa en vivo</a:t>
             </a:r>
             <a:endParaRPr lang="en-US" sz="3000" dirty="0"/>
           </a:p>
@@ -15639,12 +15639,156 @@
         </p:nvSpPr>
         <p:spPr>
           <a:xfrm>
-            <a:off x="548640" y="2788920"/>
-            <a:ext cx="1920240" cy="914400"/>
+            <a:off x="548640" y="1737360"/>
+            <a:ext cx="7863840" cy="1417320"/>
           </a:xfrm>
           <a:prstGeom prst="roundRect">
             <a:avLst>
-              <a:gd name="adj" fmla="val 12000"/>
+              <a:gd name="adj" fmla="val 9032"/>
+            </a:avLst>
+          </a:prstGeom>
+          <a:solidFill>
+            <a:schemeClr val="bg2"/>
+          </a:solidFill>
+          <a:ln/>
+        </p:spPr>
+      </p:sp>
+      <p:sp>
+        <p:nvSpPr>
+          <p:cNvPr id="8" name="Text 6"/>
+          <p:cNvSpPr txBox="1"/>
+          <p:nvPr/>
+        </p:nvSpPr>
+        <p:spPr>
+          <a:xfrm>
+            <a:off x="731520" y="1737360"/>
+            <a:ext cx="1463040" cy="1417320"/>
+          </a:xfrm>
+          <a:prstGeom prst="rect">
+            <a:avLst/>
+          </a:prstGeom>
+          <a:noFill/>
+          <a:ln/>
+        </p:spPr>
+        <p:txBody>
+          <a:bodyPr wrap="square" lIns="0" tIns="0" rIns="0" bIns="0" rtlCol="0" anchor="ctr"/>
+          <a:lstStyle/>
+          <a:p>
+            <a:pPr indent="0" marL="0">
+              <a:buNone/>
+            </a:pPr>
+            <a:r>
+              <a:rPr lang="en-US" sz="1250" b="1" spc="150" kern="0" dirty="0">
+                <a:solidFill>
+                  <a:schemeClr val="tx2"/>
+                </a:solidFill>
+              </a:rPr>
+              <a:t>CAPA BATCH</a:t>
+            </a:r>
+            <a:endParaRPr lang="en-US" sz="1250" dirty="0"/>
+          </a:p>
+          <a:p>
+            <a:pPr indent="0" marL="0">
+              <a:buNone/>
+            </a:pPr>
+            <a:r>
+              <a:rPr lang="en-US" sz="1050" dirty="0">
+                <a:solidFill>
+                  <a:schemeClr val="accent6"/>
+                </a:solidFill>
+              </a:rPr>
+              <a:t>Unidad 1 · aprende del histórico</a:t>
+            </a:r>
+            <a:endParaRPr lang="en-US" sz="1250" dirty="0"/>
+          </a:p>
+        </p:txBody>
+      </p:sp>
+      <p:sp>
+        <p:nvSpPr>
+          <p:cNvPr id="9" name="Shape 7"/>
+          <p:cNvSpPr/>
+          <p:nvPr/>
+        </p:nvSpPr>
+        <p:spPr>
+          <a:xfrm>
+            <a:off x="548640" y="3520440"/>
+            <a:ext cx="7863840" cy="1417320"/>
+          </a:xfrm>
+          <a:prstGeom prst="roundRect">
+            <a:avLst>
+              <a:gd name="adj" fmla="val 9032"/>
+            </a:avLst>
+          </a:prstGeom>
+          <a:solidFill>
+            <a:schemeClr val="bg2"/>
+          </a:solidFill>
+          <a:ln/>
+        </p:spPr>
+      </p:sp>
+      <p:sp>
+        <p:nvSpPr>
+          <p:cNvPr id="10" name="Text 8"/>
+          <p:cNvSpPr txBox="1"/>
+          <p:nvPr/>
+        </p:nvSpPr>
+        <p:spPr>
+          <a:xfrm>
+            <a:off x="731520" y="3520440"/>
+            <a:ext cx="1463040" cy="1417320"/>
+          </a:xfrm>
+          <a:prstGeom prst="rect">
+            <a:avLst/>
+          </a:prstGeom>
+          <a:noFill/>
+          <a:ln/>
+        </p:spPr>
+        <p:txBody>
+          <a:bodyPr wrap="square" lIns="0" tIns="0" rIns="0" bIns="0" rtlCol="0" anchor="ctr"/>
+          <a:lstStyle/>
+          <a:p>
+            <a:pPr indent="0" marL="0">
+              <a:buNone/>
+            </a:pPr>
+            <a:r>
+              <a:rPr lang="en-US" sz="1250" b="1" spc="150" kern="0" dirty="0">
+                <a:solidFill>
+                  <a:schemeClr val="tx2"/>
+                </a:solidFill>
+              </a:rPr>
+              <a:t>CAPA DE VELOCIDAD</a:t>
+            </a:r>
+            <a:endParaRPr lang="en-US" sz="1250" dirty="0"/>
+          </a:p>
+          <a:p>
+            <a:pPr indent="0" marL="0">
+              <a:buNone/>
+            </a:pPr>
+            <a:r>
+              <a:rPr lang="en-US" sz="1050" dirty="0">
+                <a:solidFill>
+                  <a:schemeClr val="accent6"/>
+                </a:solidFill>
+              </a:rPr>
+              <a:t>Unidad 2 · cada minuto</a:t>
+            </a:r>
+            <a:endParaRPr lang="en-US" sz="1250" dirty="0"/>
+          </a:p>
+        </p:txBody>
+      </p:sp>
+      <p:sp>
+        <p:nvSpPr>
+          <p:cNvPr id="11" name="Shape 9"/>
+          <p:cNvSpPr/>
+          <p:nvPr/>
+        </p:nvSpPr>
+        <p:spPr>
+          <a:xfrm>
+            <a:off x="2286000" y="2011680"/>
+            <a:ext cx="1828800" cy="868680"/>
+          </a:xfrm>
+          <a:prstGeom prst="roundRect">
+            <a:avLst>
+              <a:gd name="adj" fmla="val 12632"/>
             </a:avLst>
           </a:prstGeom>
           <a:solidFill>
@@ -15662,14 +15806,14 @@
       </p:sp>
       <p:sp>
         <p:nvSpPr>
-          <p:cNvPr id="8" name="Text 6"/>
-          <p:cNvSpPr txBox="1"/>
-          <p:nvPr/>
-        </p:nvSpPr>
-        <p:spPr>
-          <a:xfrm>
-            <a:off x="548640" y="2788920"/>
-            <a:ext cx="1920240" cy="914400"/>
+          <p:cNvPr id="12" name="Text 10"/>
+          <p:cNvSpPr txBox="1"/>
+          <p:nvPr/>
+        </p:nvSpPr>
+        <p:spPr>
+          <a:xfrm>
+            <a:off x="2286000" y="2011680"/>
+            <a:ext cx="1828800" cy="868680"/>
           </a:xfrm>
           <a:prstGeom prst="rect">
             <a:avLst/>
@@ -15690,7 +15834,7 @@
                   <a:schemeClr val="bg1"/>
                 </a:solidFill>
               </a:rPr>
-              <a:t>Binance</a:t>
+              <a:t>ZIP históricos</a:t>
             </a:r>
             <a:endParaRPr lang="en-US" sz="1500" dirty="0"/>
           </a:p>
@@ -15704,7 +15848,7 @@
                   <a:srgbClr val="E5E9F0"/>
                 </a:solidFill>
               </a:rPr>
-              <a:t>WebSocket y REST</a:t>
+              <a:t>114 meses · SHA256</a:t>
             </a:r>
             <a:endParaRPr lang="en-US" sz="1500" dirty="0"/>
           </a:p>
@@ -15712,14 +15856,14 @@
       </p:sp>
       <p:sp>
         <p:nvSpPr>
-          <p:cNvPr id="9" name="Shape 7"/>
+          <p:cNvPr id="13" name="Shape 11"/>
           <p:cNvSpPr/>
           <p:nvPr/>
         </p:nvSpPr>
         <p:spPr>
           <a:xfrm>
-            <a:off x="3063240" y="1828800"/>
-            <a:ext cx="2103120" cy="868680"/>
+            <a:off x="4389120" y="2011680"/>
+            <a:ext cx="1828800" cy="868680"/>
           </a:xfrm>
           <a:prstGeom prst="roundRect">
             <a:avLst>
@@ -15727,7 +15871,7 @@
             </a:avLst>
           </a:prstGeom>
           <a:solidFill>
-            <a:schemeClr val="accent3"/>
+            <a:schemeClr val="tx2"/>
           </a:solidFill>
           <a:ln/>
           <a:effectLst>
@@ -15741,14 +15885,14 @@
       </p:sp>
       <p:sp>
         <p:nvSpPr>
-          <p:cNvPr id="10" name="Text 8"/>
-          <p:cNvSpPr txBox="1"/>
-          <p:nvPr/>
-        </p:nvSpPr>
-        <p:spPr>
-          <a:xfrm>
-            <a:off x="3063240" y="1828800"/>
-            <a:ext cx="2103120" cy="868680"/>
+          <p:cNvPr id="14" name="Text 12"/>
+          <p:cNvSpPr txBox="1"/>
+          <p:nvPr/>
+        </p:nvSpPr>
+        <p:spPr>
+          <a:xfrm>
+            <a:off x="4389120" y="2011680"/>
+            <a:ext cx="1828800" cy="868680"/>
           </a:xfrm>
           <a:prstGeom prst="rect">
             <a:avLst/>
@@ -15769,7 +15913,7 @@
                   <a:schemeClr val="bg1"/>
                 </a:solidFill>
               </a:rPr>
-              <a:t>Kafka</a:t>
+              <a:t>PySpark</a:t>
             </a:r>
             <a:endParaRPr lang="en-US" sz="1500" dirty="0"/>
           </a:p>
@@ -15783,7 +15927,7 @@
                   <a:srgbClr val="E5E9F0"/>
                 </a:solidFill>
               </a:rPr>
-              <a:t>market.trades</a:t>
+              <a:t>calidad · Parquet</a:t>
             </a:r>
             <a:endParaRPr lang="en-US" sz="1500" dirty="0"/>
           </a:p>
@@ -15791,14 +15935,14 @@
       </p:sp>
       <p:sp>
         <p:nvSpPr>
-          <p:cNvPr id="11" name="Shape 9"/>
+          <p:cNvPr id="15" name="Shape 13"/>
           <p:cNvSpPr/>
           <p:nvPr/>
         </p:nvSpPr>
         <p:spPr>
           <a:xfrm>
-            <a:off x="3063240" y="3794760"/>
-            <a:ext cx="2103120" cy="868680"/>
+            <a:off x="6492240" y="2011680"/>
+            <a:ext cx="1737360" cy="868680"/>
           </a:xfrm>
           <a:prstGeom prst="roundRect">
             <a:avLst>
@@ -15806,7 +15950,7 @@
             </a:avLst>
           </a:prstGeom>
           <a:solidFill>
-            <a:schemeClr val="accent3"/>
+            <a:schemeClr val="tx2"/>
           </a:solidFill>
           <a:ln/>
           <a:effectLst>
@@ -15820,14 +15964,14 @@
       </p:sp>
       <p:sp>
         <p:nvSpPr>
-          <p:cNvPr id="12" name="Text 10"/>
-          <p:cNvSpPr txBox="1"/>
-          <p:nvPr/>
-        </p:nvSpPr>
-        <p:spPr>
-          <a:xfrm>
-            <a:off x="3063240" y="3794760"/>
-            <a:ext cx="2103120" cy="868680"/>
+          <p:cNvPr id="16" name="Text 14"/>
+          <p:cNvSpPr txBox="1"/>
+          <p:nvPr/>
+        </p:nvSpPr>
+        <p:spPr>
+          <a:xfrm>
+            <a:off x="6492240" y="2011680"/>
+            <a:ext cx="1737360" cy="868680"/>
           </a:xfrm>
           <a:prstGeom prst="rect">
             <a:avLst/>
@@ -15848,7 +15992,7 @@
                   <a:schemeClr val="bg1"/>
                 </a:solidFill>
               </a:rPr>
-              <a:t>Kafka</a:t>
+              <a:t>MLlib</a:t>
             </a:r>
             <a:endParaRPr lang="en-US" sz="1500" dirty="0"/>
           </a:p>
@@ -15862,7 +16006,7 @@
                   <a:srgbClr val="E5E9F0"/>
                 </a:solidFill>
               </a:rPr>
-              <a:t>market.klines</a:t>
+              <a:t>4 modelos</a:t>
             </a:r>
             <a:endParaRPr lang="en-US" sz="1500" dirty="0"/>
           </a:p>
@@ -15870,18 +16014,18 @@
       </p:sp>
       <p:sp>
         <p:nvSpPr>
-          <p:cNvPr id="13" name="Shape 11"/>
+          <p:cNvPr id="17" name="Shape 15"/>
           <p:cNvSpPr/>
           <p:nvPr/>
         </p:nvSpPr>
         <p:spPr>
           <a:xfrm>
-            <a:off x="5760720" y="2788920"/>
-            <a:ext cx="1920240" cy="914400"/>
+            <a:off x="2286000" y="3794760"/>
+            <a:ext cx="1828800" cy="868680"/>
           </a:xfrm>
           <a:prstGeom prst="roundRect">
             <a:avLst>
-              <a:gd name="adj" fmla="val 12000"/>
+              <a:gd name="adj" fmla="val 12632"/>
             </a:avLst>
           </a:prstGeom>
           <a:solidFill>
@@ -15899,14 +16043,14 @@
       </p:sp>
       <p:sp>
         <p:nvSpPr>
-          <p:cNvPr id="14" name="Text 12"/>
-          <p:cNvSpPr txBox="1"/>
-          <p:nvPr/>
-        </p:nvSpPr>
-        <p:spPr>
-          <a:xfrm>
-            <a:off x="5760720" y="2788920"/>
-            <a:ext cx="1920240" cy="914400"/>
+          <p:cNvPr id="18" name="Text 16"/>
+          <p:cNvSpPr txBox="1"/>
+          <p:nvPr/>
+        </p:nvSpPr>
+        <p:spPr>
+          <a:xfrm>
+            <a:off x="2286000" y="3794760"/>
+            <a:ext cx="1828800" cy="868680"/>
           </a:xfrm>
           <a:prstGeom prst="rect">
             <a:avLst/>
@@ -15927,7 +16071,7 @@
                   <a:schemeClr val="bg1"/>
                 </a:solidFill>
               </a:rPr>
-              <a:t>Spark</a:t>
+              <a:t>Binance</a:t>
             </a:r>
             <a:endParaRPr lang="en-US" sz="1500" dirty="0"/>
           </a:p>
@@ -15941,7 +16085,7 @@
                   <a:srgbClr val="E5E9F0"/>
                 </a:solidFill>
               </a:rPr>
-              <a:t>4 consultas</a:t>
+              <a:t>WebSocket y REST</a:t>
             </a:r>
             <a:endParaRPr lang="en-US" sz="1500" dirty="0"/>
           </a:p>
@@ -15949,14 +16093,14 @@
       </p:sp>
       <p:sp>
         <p:nvSpPr>
-          <p:cNvPr id="15" name="Shape 13"/>
+          <p:cNvPr id="19" name="Shape 17"/>
           <p:cNvSpPr/>
           <p:nvPr/>
         </p:nvSpPr>
         <p:spPr>
           <a:xfrm>
-            <a:off x="8275320" y="1828800"/>
-            <a:ext cx="2011680" cy="868680"/>
+            <a:off x="4389120" y="3794760"/>
+            <a:ext cx="1828800" cy="868680"/>
           </a:xfrm>
           <a:prstGeom prst="roundRect">
             <a:avLst>
@@ -15964,7 +16108,7 @@
             </a:avLst>
           </a:prstGeom>
           <a:solidFill>
-            <a:schemeClr val="accent2"/>
+            <a:schemeClr val="accent3"/>
           </a:solidFill>
           <a:ln/>
           <a:effectLst>
@@ -15978,14 +16122,14 @@
       </p:sp>
       <p:sp>
         <p:nvSpPr>
-          <p:cNvPr id="16" name="Text 14"/>
-          <p:cNvSpPr txBox="1"/>
-          <p:nvPr/>
-        </p:nvSpPr>
-        <p:spPr>
-          <a:xfrm>
-            <a:off x="8275320" y="1828800"/>
-            <a:ext cx="2011680" cy="868680"/>
+          <p:cNvPr id="20" name="Text 18"/>
+          <p:cNvSpPr txBox="1"/>
+          <p:nvPr/>
+        </p:nvSpPr>
+        <p:spPr>
+          <a:xfrm>
+            <a:off x="4389120" y="3794760"/>
+            <a:ext cx="1828800" cy="868680"/>
           </a:xfrm>
           <a:prstGeom prst="rect">
             <a:avLst/>
@@ -16006,22 +16150,36 @@
                   <a:schemeClr val="bg1"/>
                 </a:solidFill>
               </a:rPr>
-              <a:t>PostgreSQL</a:t>
+              <a:t>Kafka</a:t>
             </a:r>
             <a:endParaRPr lang="en-US" sz="1500" dirty="0"/>
           </a:p>
-        </p:txBody>
-      </p:sp>
-      <p:sp>
-        <p:nvSpPr>
-          <p:cNvPr id="17" name="Shape 15"/>
+          <a:p>
+            <a:pPr algn="ctr" indent="0" marL="0">
+              <a:buNone/>
+            </a:pPr>
+            <a:r>
+              <a:rPr lang="en-US" sz="1100" dirty="0">
+                <a:solidFill>
+                  <a:srgbClr val="E5E9F0"/>
+                </a:solidFill>
+              </a:rPr>
+              <a:t>trades · klines</a:t>
+            </a:r>
+            <a:endParaRPr lang="en-US" sz="1500" dirty="0"/>
+          </a:p>
+        </p:txBody>
+      </p:sp>
+      <p:sp>
+        <p:nvSpPr>
+          <p:cNvPr id="21" name="Shape 19"/>
           <p:cNvSpPr/>
           <p:nvPr/>
         </p:nvSpPr>
         <p:spPr>
           <a:xfrm>
-            <a:off x="8275320" y="3291840"/>
-            <a:ext cx="2011680" cy="868680"/>
+            <a:off x="6492240" y="3794760"/>
+            <a:ext cx="1737360" cy="868680"/>
           </a:xfrm>
           <a:prstGeom prst="roundRect">
             <a:avLst>
@@ -16029,7 +16187,7 @@
             </a:avLst>
           </a:prstGeom>
           <a:solidFill>
-            <a:schemeClr val="accent2"/>
+            <a:schemeClr val="accent3"/>
           </a:solidFill>
           <a:ln/>
           <a:effectLst>
@@ -16043,14 +16201,14 @@
       </p:sp>
       <p:sp>
         <p:nvSpPr>
-          <p:cNvPr id="18" name="Text 16"/>
-          <p:cNvSpPr txBox="1"/>
-          <p:nvPr/>
-        </p:nvSpPr>
-        <p:spPr>
-          <a:xfrm>
-            <a:off x="8275320" y="3291840"/>
-            <a:ext cx="2011680" cy="868680"/>
+          <p:cNvPr id="22" name="Text 20"/>
+          <p:cNvSpPr txBox="1"/>
+          <p:nvPr/>
+        </p:nvSpPr>
+        <p:spPr>
+          <a:xfrm>
+            <a:off x="6492240" y="3794760"/>
+            <a:ext cx="1737360" cy="868680"/>
           </a:xfrm>
           <a:prstGeom prst="rect">
             <a:avLst/>
@@ -16071,7 +16229,7 @@
                   <a:schemeClr val="bg1"/>
                 </a:solidFill>
               </a:rPr>
-              <a:t>Grafana</a:t>
+              <a:t>Spark Streaming</a:t>
             </a:r>
             <a:endParaRPr lang="en-US" sz="1500" dirty="0"/>
           </a:p>
@@ -16085,7 +16243,7 @@
                   <a:srgbClr val="E5E9F0"/>
                 </a:solidFill>
               </a:rPr>
-              <a:t>KPIs + predicción</a:t>
+              <a:t>inferencia</a:t>
             </a:r>
             <a:endParaRPr lang="en-US" sz="1500" dirty="0"/>
           </a:p>
@@ -16093,22 +16251,238 @@
       </p:sp>
       <p:sp>
         <p:nvSpPr>
-          <p:cNvPr id="19" name="Shape 17"/>
+          <p:cNvPr id="23" name="Shape 21"/>
           <p:cNvSpPr/>
           <p:nvPr/>
         </p:nvSpPr>
         <p:spPr>
           <a:xfrm>
-            <a:off x="8275320" y="4754880"/>
-            <a:ext cx="2011680" cy="868680"/>
+            <a:off x="4114800" y="2441448"/>
+            <a:ext cx="274320" cy="914"/>
+          </a:xfrm>
+          <a:prstGeom prst="line">
+            <a:avLst/>
+          </a:prstGeom>
+          <a:noFill/>
+          <a:ln w="22225">
+            <a:solidFill>
+              <a:srgbClr val="9AA3B2"/>
+            </a:solidFill>
+            <a:prstDash val="solid"/>
+            <a:tailEnd type="triangle"/>
+          </a:ln>
+        </p:spPr>
+      </p:sp>
+      <p:sp>
+        <p:nvSpPr>
+          <p:cNvPr id="24" name="Shape 22"/>
+          <p:cNvSpPr/>
+          <p:nvPr/>
+        </p:nvSpPr>
+        <p:spPr>
+          <a:xfrm>
+            <a:off x="6217920" y="2441448"/>
+            <a:ext cx="274320" cy="914"/>
+          </a:xfrm>
+          <a:prstGeom prst="line">
+            <a:avLst/>
+          </a:prstGeom>
+          <a:noFill/>
+          <a:ln w="22225">
+            <a:solidFill>
+              <a:srgbClr val="9AA3B2"/>
+            </a:solidFill>
+            <a:prstDash val="solid"/>
+            <a:tailEnd type="triangle"/>
+          </a:ln>
+        </p:spPr>
+      </p:sp>
+      <p:sp>
+        <p:nvSpPr>
+          <p:cNvPr id="25" name="Shape 23"/>
+          <p:cNvSpPr/>
+          <p:nvPr/>
+        </p:nvSpPr>
+        <p:spPr>
+          <a:xfrm>
+            <a:off x="4114800" y="4224528"/>
+            <a:ext cx="274320" cy="914"/>
+          </a:xfrm>
+          <a:prstGeom prst="line">
+            <a:avLst/>
+          </a:prstGeom>
+          <a:noFill/>
+          <a:ln w="22225">
+            <a:solidFill>
+              <a:srgbClr val="9AA3B2"/>
+            </a:solidFill>
+            <a:prstDash val="solid"/>
+            <a:tailEnd type="triangle"/>
+          </a:ln>
+        </p:spPr>
+      </p:sp>
+      <p:sp>
+        <p:nvSpPr>
+          <p:cNvPr id="26" name="Shape 24"/>
+          <p:cNvSpPr/>
+          <p:nvPr/>
+        </p:nvSpPr>
+        <p:spPr>
+          <a:xfrm>
+            <a:off x="6217920" y="4224528"/>
+            <a:ext cx="274320" cy="914"/>
+          </a:xfrm>
+          <a:prstGeom prst="line">
+            <a:avLst/>
+          </a:prstGeom>
+          <a:noFill/>
+          <a:ln w="22225">
+            <a:solidFill>
+              <a:srgbClr val="9AA3B2"/>
+            </a:solidFill>
+            <a:prstDash val="solid"/>
+            <a:tailEnd type="triangle"/>
+          </a:ln>
+        </p:spPr>
+      </p:sp>
+      <p:sp>
+        <p:nvSpPr>
+          <p:cNvPr id="27" name="Shape 25"/>
+          <p:cNvSpPr/>
+          <p:nvPr/>
+        </p:nvSpPr>
+        <p:spPr>
+          <a:xfrm>
+            <a:off x="7360920" y="2880360"/>
+            <a:ext cx="914" cy="914400"/>
+          </a:xfrm>
+          <a:prstGeom prst="line">
+            <a:avLst/>
+          </a:prstGeom>
+          <a:noFill/>
+          <a:ln w="22225">
+            <a:solidFill>
+              <a:srgbClr val="9AA3B2"/>
+            </a:solidFill>
+            <a:prstDash val="solid"/>
+            <a:tailEnd type="triangle"/>
+          </a:ln>
+        </p:spPr>
+      </p:sp>
+      <p:sp>
+        <p:nvSpPr>
+          <p:cNvPr id="28" name="Text 26"/>
+          <p:cNvSpPr txBox="1"/>
+          <p:nvPr/>
+        </p:nvSpPr>
+        <p:spPr>
+          <a:xfrm>
+            <a:off x="7424928" y="3108960"/>
+            <a:ext cx="914400" cy="274320"/>
+          </a:xfrm>
+          <a:prstGeom prst="rect">
+            <a:avLst/>
+          </a:prstGeom>
+          <a:noFill/>
+          <a:ln/>
+        </p:spPr>
+        <p:txBody>
+          <a:bodyPr wrap="square" lIns="0" tIns="0" rIns="0" bIns="0" rtlCol="0" anchor="ctr"/>
+          <a:lstStyle/>
+          <a:p>
+            <a:pPr indent="0" marL="0">
+              <a:buNone/>
+            </a:pPr>
+            <a:r>
+              <a:rPr lang="en-US" sz="1050" b="1" i="1" dirty="0">
+                <a:solidFill>
+                  <a:schemeClr val="accent1"/>
+                </a:solidFill>
+              </a:rPr>
+              <a:t>modelos</a:t>
+            </a:r>
+            <a:endParaRPr lang="en-US" sz="1050" dirty="0"/>
+          </a:p>
+        </p:txBody>
+      </p:sp>
+      <p:sp>
+        <p:nvSpPr>
+          <p:cNvPr id="29" name="Shape 27"/>
+          <p:cNvSpPr/>
+          <p:nvPr/>
+        </p:nvSpPr>
+        <p:spPr>
+          <a:xfrm>
+            <a:off x="8732520" y="1737360"/>
+            <a:ext cx="2926080" cy="3200400"/>
           </a:xfrm>
           <a:prstGeom prst="roundRect">
             <a:avLst>
-              <a:gd name="adj" fmla="val 12632"/>
+              <a:gd name="adj" fmla="val 4375"/>
             </a:avLst>
           </a:prstGeom>
           <a:solidFill>
-            <a:schemeClr val="accent4"/>
+            <a:schemeClr val="accent2">
+              <a:alpha val="12000"/>
+            </a:schemeClr>
+          </a:solidFill>
+          <a:ln/>
+        </p:spPr>
+      </p:sp>
+      <p:sp>
+        <p:nvSpPr>
+          <p:cNvPr id="30" name="Text 28"/>
+          <p:cNvSpPr txBox="1"/>
+          <p:nvPr/>
+        </p:nvSpPr>
+        <p:spPr>
+          <a:xfrm>
+            <a:off x="8915400" y="1847088"/>
+            <a:ext cx="2560320" cy="320040"/>
+          </a:xfrm>
+          <a:prstGeom prst="rect">
+            <a:avLst/>
+          </a:prstGeom>
+          <a:noFill/>
+          <a:ln/>
+        </p:spPr>
+        <p:txBody>
+          <a:bodyPr wrap="square" lIns="0" tIns="0" rIns="0" bIns="0" rtlCol="0" anchor="ctr"/>
+          <a:lstStyle/>
+          <a:p>
+            <a:pPr indent="0" marL="0">
+              <a:buNone/>
+            </a:pPr>
+            <a:r>
+              <a:rPr lang="en-US" sz="1250" b="1" spc="150" kern="0" dirty="0">
+                <a:solidFill>
+                  <a:schemeClr val="accent2"/>
+                </a:solidFill>
+              </a:rPr>
+              <a:t>CAPA DE SERVICIO</a:t>
+            </a:r>
+            <a:endParaRPr lang="en-US" sz="1250" dirty="0"/>
+          </a:p>
+        </p:txBody>
+      </p:sp>
+      <p:sp>
+        <p:nvSpPr>
+          <p:cNvPr id="31" name="Shape 29"/>
+          <p:cNvSpPr/>
+          <p:nvPr/>
+        </p:nvSpPr>
+        <p:spPr>
+          <a:xfrm>
+            <a:off x="8961120" y="2286000"/>
+            <a:ext cx="2468880" cy="822960"/>
+          </a:xfrm>
+          <a:prstGeom prst="roundRect">
+            <a:avLst>
+              <a:gd name="adj" fmla="val 13333"/>
+            </a:avLst>
+          </a:prstGeom>
+          <a:solidFill>
+            <a:schemeClr val="accent2"/>
           </a:solidFill>
           <a:ln/>
           <a:effectLst>
@@ -16122,14 +16496,14 @@
       </p:sp>
       <p:sp>
         <p:nvSpPr>
-          <p:cNvPr id="20" name="Text 18"/>
-          <p:cNvSpPr txBox="1"/>
-          <p:nvPr/>
-        </p:nvSpPr>
-        <p:spPr>
-          <a:xfrm>
-            <a:off x="8275320" y="4754880"/>
-            <a:ext cx="2011680" cy="868680"/>
+          <p:cNvPr id="32" name="Text 30"/>
+          <p:cNvSpPr txBox="1"/>
+          <p:nvPr/>
+        </p:nvSpPr>
+        <p:spPr>
+          <a:xfrm>
+            <a:off x="8961120" y="2286000"/>
+            <a:ext cx="2468880" cy="822960"/>
           </a:xfrm>
           <a:prstGeom prst="rect">
             <a:avLst/>
@@ -16150,7 +16524,7 @@
                   <a:schemeClr val="bg1"/>
                 </a:solidFill>
               </a:rPr>
-              <a:t>Prometheus</a:t>
+              <a:t>PostgreSQL</a:t>
             </a:r>
             <a:endParaRPr lang="en-US" sz="1500" dirty="0"/>
           </a:p>
@@ -16164,7 +16538,7 @@
                   <a:srgbClr val="E5E9F0"/>
                 </a:solidFill>
               </a:rPr>
-              <a:t>11 alertas</a:t>
+              <a:t>vistas batch + en vivo</a:t>
             </a:r>
             <a:endParaRPr lang="en-US" sz="1500" dirty="0"/>
           </a:p>
@@ -16172,14 +16546,93 @@
       </p:sp>
       <p:sp>
         <p:nvSpPr>
-          <p:cNvPr id="21" name="Shape 19"/>
+          <p:cNvPr id="33" name="Shape 31"/>
           <p:cNvSpPr/>
           <p:nvPr/>
         </p:nvSpPr>
         <p:spPr>
-          <a:xfrm flipV="1">
-            <a:off x="2468880" y="2286000"/>
-            <a:ext cx="594360" cy="822960"/>
+          <a:xfrm>
+            <a:off x="8961120" y="3611880"/>
+            <a:ext cx="2468880" cy="822960"/>
+          </a:xfrm>
+          <a:prstGeom prst="roundRect">
+            <a:avLst>
+              <a:gd name="adj" fmla="val 13333"/>
+            </a:avLst>
+          </a:prstGeom>
+          <a:solidFill>
+            <a:schemeClr val="accent2"/>
+          </a:solidFill>
+          <a:ln/>
+          <a:effectLst>
+            <a:outerShdw sx="100000" sy="100000" kx="0" ky="0" algn="bl" rotWithShape="0" blurRad="127000" dist="38100" dir="5400000">
+              <a:srgbClr val="14213D">
+                <a:alpha val="16000"/>
+              </a:srgbClr>
+            </a:outerShdw>
+          </a:effectLst>
+        </p:spPr>
+      </p:sp>
+      <p:sp>
+        <p:nvSpPr>
+          <p:cNvPr id="34" name="Text 32"/>
+          <p:cNvSpPr txBox="1"/>
+          <p:nvPr/>
+        </p:nvSpPr>
+        <p:spPr>
+          <a:xfrm>
+            <a:off x="8961120" y="3611880"/>
+            <a:ext cx="2468880" cy="822960"/>
+          </a:xfrm>
+          <a:prstGeom prst="rect">
+            <a:avLst/>
+          </a:prstGeom>
+          <a:noFill/>
+          <a:ln/>
+        </p:spPr>
+        <p:txBody>
+          <a:bodyPr wrap="square" lIns="635" tIns="635" rIns="635" bIns="635" rtlCol="0" anchor="ctr"/>
+          <a:lstStyle/>
+          <a:p>
+            <a:pPr algn="ctr" indent="0" marL="0">
+              <a:buNone/>
+            </a:pPr>
+            <a:r>
+              <a:rPr lang="en-US" sz="1500" b="1" dirty="0">
+                <a:solidFill>
+                  <a:schemeClr val="bg1"/>
+                </a:solidFill>
+              </a:rPr>
+              <a:t>Grafana</a:t>
+            </a:r>
+            <a:endParaRPr lang="en-US" sz="1500" dirty="0"/>
+          </a:p>
+          <a:p>
+            <a:pPr algn="ctr" indent="0" marL="0">
+              <a:buNone/>
+            </a:pPr>
+            <a:r>
+              <a:rPr lang="en-US" sz="1100" dirty="0">
+                <a:solidFill>
+                  <a:srgbClr val="E5E9F0"/>
+                </a:solidFill>
+              </a:rPr>
+              <a:t>KPIs + predicción</a:t>
+            </a:r>
+            <a:endParaRPr lang="en-US" sz="1500" dirty="0"/>
+          </a:p>
+        </p:txBody>
+      </p:sp>
+      <p:sp>
+        <p:nvSpPr>
+          <p:cNvPr id="35" name="Shape 33"/>
+          <p:cNvSpPr/>
+          <p:nvPr/>
+        </p:nvSpPr>
+        <p:spPr>
+          <a:xfrm>
+            <a:off x="10195560" y="3108960"/>
+            <a:ext cx="914" cy="502920"/>
           </a:xfrm>
           <a:prstGeom prst="line">
             <a:avLst/>
@@ -16196,14 +16649,14 @@
       </p:sp>
       <p:sp>
         <p:nvSpPr>
-          <p:cNvPr id="22" name="Shape 20"/>
+          <p:cNvPr id="36" name="Shape 34"/>
           <p:cNvSpPr/>
           <p:nvPr/>
         </p:nvSpPr>
         <p:spPr>
           <a:xfrm>
-            <a:off x="2468880" y="3383280"/>
-            <a:ext cx="594360" cy="822960"/>
+            <a:off x="8229600" y="2441448"/>
+            <a:ext cx="731520" cy="164592"/>
           </a:xfrm>
           <a:prstGeom prst="line">
             <a:avLst/>
@@ -16220,14 +16673,14 @@
       </p:sp>
       <p:sp>
         <p:nvSpPr>
-          <p:cNvPr id="23" name="Shape 21"/>
+          <p:cNvPr id="37" name="Shape 35"/>
           <p:cNvSpPr/>
           <p:nvPr/>
         </p:nvSpPr>
         <p:spPr>
-          <a:xfrm>
-            <a:off x="5166360" y="2286000"/>
-            <a:ext cx="594360" cy="777240"/>
+          <a:xfrm flipV="1">
+            <a:off x="8229600" y="2834640"/>
+            <a:ext cx="731520" cy="1389888"/>
           </a:xfrm>
           <a:prstGeom prst="line">
             <a:avLst/>
@@ -16244,130 +16697,204 @@
       </p:sp>
       <p:sp>
         <p:nvSpPr>
-          <p:cNvPr id="24" name="Shape 22"/>
+          <p:cNvPr id="38" name="Text 36"/>
+          <p:cNvSpPr txBox="1"/>
+          <p:nvPr/>
+        </p:nvSpPr>
+        <p:spPr>
+          <a:xfrm>
+            <a:off x="8732520" y="5029200"/>
+            <a:ext cx="2926080" cy="274320"/>
+          </a:xfrm>
+          <a:prstGeom prst="rect">
+            <a:avLst/>
+          </a:prstGeom>
+          <a:noFill/>
+          <a:ln/>
+        </p:spPr>
+        <p:txBody>
+          <a:bodyPr wrap="square" lIns="0" tIns="0" rIns="0" bIns="0" rtlCol="0" anchor="ctr"/>
+          <a:lstStyle/>
+          <a:p>
+            <a:pPr indent="0" marL="0">
+              <a:buNone/>
+            </a:pPr>
+            <a:r>
+              <a:rPr lang="en-US" sz="1050" b="1" dirty="0">
+                <a:solidFill>
+                  <a:schemeClr val="accent4"/>
+                </a:solidFill>
+              </a:rPr>
+              <a:t>Prometheus vigila todo el pipeline · 11 alertas</a:t>
+            </a:r>
+            <a:endParaRPr lang="en-US" sz="1050" dirty="0"/>
+          </a:p>
+        </p:txBody>
+      </p:sp>
+      <p:sp>
+        <p:nvSpPr>
+          <p:cNvPr id="39" name="Shape 37"/>
           <p:cNvSpPr/>
           <p:nvPr/>
         </p:nvSpPr>
         <p:spPr>
-          <a:xfrm flipV="1">
-            <a:off x="5166360" y="3429000"/>
-            <a:ext cx="594360" cy="777240"/>
-          </a:xfrm>
-          <a:prstGeom prst="line">
-            <a:avLst/>
-          </a:prstGeom>
-          <a:noFill/>
-          <a:ln w="22225">
-            <a:solidFill>
-              <a:srgbClr val="9AA3B2"/>
-            </a:solidFill>
-            <a:prstDash val="solid"/>
-            <a:tailEnd type="triangle"/>
-          </a:ln>
-        </p:spPr>
-      </p:sp>
-      <p:sp>
-        <p:nvSpPr>
-          <p:cNvPr id="25" name="Shape 23"/>
+          <a:xfrm>
+            <a:off x="548640" y="5394960"/>
+            <a:ext cx="146304" cy="146304"/>
+          </a:xfrm>
+          <a:prstGeom prst="ellipse">
+            <a:avLst/>
+          </a:prstGeom>
+          <a:solidFill>
+            <a:schemeClr val="accent1"/>
+          </a:solidFill>
+          <a:ln/>
+        </p:spPr>
+      </p:sp>
+      <p:sp>
+        <p:nvSpPr>
+          <p:cNvPr id="40" name="Text 38"/>
+          <p:cNvSpPr txBox="1"/>
+          <p:nvPr/>
+        </p:nvSpPr>
+        <p:spPr>
+          <a:xfrm>
+            <a:off x="804672" y="5321808"/>
+            <a:ext cx="2377440" cy="685800"/>
+          </a:xfrm>
+          <a:prstGeom prst="rect">
+            <a:avLst/>
+          </a:prstGeom>
+          <a:noFill/>
+          <a:ln/>
+        </p:spPr>
+        <p:txBody>
+          <a:bodyPr wrap="square" lIns="0" tIns="0" rIns="0" bIns="0" rtlCol="0" anchor="t"/>
+          <a:lstStyle/>
+          <a:p>
+            <a:pPr indent="0" marL="0">
+              <a:buNone/>
+            </a:pPr>
+            <a:r>
+              <a:rPr lang="en-US" sz="1250" b="1" dirty="0">
+                <a:solidFill>
+                  <a:schemeClr val="tx2"/>
+                </a:solidFill>
+              </a:rPr>
+              <a:t>Batch: </a:t>
+            </a:r>
+            <a:pPr indent="0" marL="0">
+              <a:buNone/>
+            </a:pPr>
+            <a:r>
+              <a:rPr lang="en-US" sz="1250" dirty="0">
+                <a:solidFill>
+                  <a:schemeClr val="tx1"/>
+                </a:solidFill>
+              </a:rPr>
+              <a:t>aprende con 4,99 millones de velas (2022–2026)</a:t>
+            </a:r>
+            <a:endParaRPr lang="en-US" sz="1250" dirty="0"/>
+          </a:p>
+        </p:txBody>
+      </p:sp>
+      <p:sp>
+        <p:nvSpPr>
+          <p:cNvPr id="41" name="Shape 39"/>
           <p:cNvSpPr/>
           <p:nvPr/>
         </p:nvSpPr>
         <p:spPr>
-          <a:xfrm flipV="1">
-            <a:off x="7680960" y="2286000"/>
-            <a:ext cx="594360" cy="777240"/>
-          </a:xfrm>
-          <a:prstGeom prst="line">
-            <a:avLst/>
-          </a:prstGeom>
-          <a:noFill/>
-          <a:ln w="22225">
-            <a:solidFill>
-              <a:srgbClr val="9AA3B2"/>
-            </a:solidFill>
-            <a:prstDash val="solid"/>
-            <a:tailEnd type="triangle"/>
-          </a:ln>
-        </p:spPr>
-      </p:sp>
-      <p:sp>
-        <p:nvSpPr>
-          <p:cNvPr id="26" name="Shape 24"/>
+          <a:xfrm>
+            <a:off x="3291840" y="5394960"/>
+            <a:ext cx="146304" cy="146304"/>
+          </a:xfrm>
+          <a:prstGeom prst="ellipse">
+            <a:avLst/>
+          </a:prstGeom>
+          <a:solidFill>
+            <a:schemeClr val="accent1"/>
+          </a:solidFill>
+          <a:ln/>
+        </p:spPr>
+      </p:sp>
+      <p:sp>
+        <p:nvSpPr>
+          <p:cNvPr id="42" name="Text 40"/>
+          <p:cNvSpPr txBox="1"/>
+          <p:nvPr/>
+        </p:nvSpPr>
+        <p:spPr>
+          <a:xfrm>
+            <a:off x="3547872" y="5321808"/>
+            <a:ext cx="2377440" cy="685800"/>
+          </a:xfrm>
+          <a:prstGeom prst="rect">
+            <a:avLst/>
+          </a:prstGeom>
+          <a:noFill/>
+          <a:ln/>
+        </p:spPr>
+        <p:txBody>
+          <a:bodyPr wrap="square" lIns="0" tIns="0" rIns="0" bIns="0" rtlCol="0" anchor="t"/>
+          <a:lstStyle/>
+          <a:p>
+            <a:pPr indent="0" marL="0">
+              <a:buNone/>
+            </a:pPr>
+            <a:r>
+              <a:rPr lang="en-US" sz="1250" b="1" dirty="0">
+                <a:solidFill>
+                  <a:schemeClr val="tx2"/>
+                </a:solidFill>
+              </a:rPr>
+              <a:t>Velocidad: </a:t>
+            </a:r>
+            <a:pPr indent="0" marL="0">
+              <a:buNone/>
+            </a:pPr>
+            <a:r>
+              <a:rPr lang="en-US" sz="1250" dirty="0">
+                <a:solidFill>
+                  <a:schemeClr val="tx1"/>
+                </a:solidFill>
+              </a:rPr>
+              <a:t>aplica esos modelos a cada vela en vivo</a:t>
+            </a:r>
+            <a:endParaRPr lang="en-US" sz="1250" dirty="0"/>
+          </a:p>
+        </p:txBody>
+      </p:sp>
+      <p:sp>
+        <p:nvSpPr>
+          <p:cNvPr id="43" name="Shape 41"/>
           <p:cNvSpPr/>
           <p:nvPr/>
         </p:nvSpPr>
         <p:spPr>
           <a:xfrm>
-            <a:off x="9281160" y="2697480"/>
-            <a:ext cx="914" cy="594360"/>
-          </a:xfrm>
-          <a:prstGeom prst="line">
-            <a:avLst/>
-          </a:prstGeom>
-          <a:noFill/>
-          <a:ln w="22225">
-            <a:solidFill>
-              <a:srgbClr val="9AA3B2"/>
-            </a:solidFill>
-            <a:prstDash val="solid"/>
-            <a:tailEnd type="triangle"/>
-          </a:ln>
-        </p:spPr>
-      </p:sp>
-      <p:sp>
-        <p:nvSpPr>
-          <p:cNvPr id="27" name="Shape 25"/>
-          <p:cNvSpPr/>
-          <p:nvPr/>
-        </p:nvSpPr>
-        <p:spPr>
-          <a:xfrm flipV="1">
-            <a:off x="9281160" y="4160520"/>
-            <a:ext cx="914" cy="594360"/>
-          </a:xfrm>
-          <a:prstGeom prst="line">
-            <a:avLst/>
-          </a:prstGeom>
-          <a:noFill/>
-          <a:ln w="22225">
-            <a:solidFill>
-              <a:srgbClr val="9AA3B2"/>
-            </a:solidFill>
-            <a:prstDash val="solid"/>
-            <a:tailEnd type="triangle"/>
-          </a:ln>
-        </p:spPr>
-      </p:sp>
-      <p:sp>
-        <p:nvSpPr>
-          <p:cNvPr id="28" name="Shape 26"/>
-          <p:cNvSpPr/>
-          <p:nvPr/>
-        </p:nvSpPr>
-        <p:spPr>
-          <a:xfrm>
-            <a:off x="10607040" y="2103120"/>
+            <a:off x="6035040" y="5394960"/>
             <a:ext cx="146304" cy="146304"/>
           </a:xfrm>
           <a:prstGeom prst="ellipse">
             <a:avLst/>
           </a:prstGeom>
           <a:solidFill>
-            <a:schemeClr val="accent2"/>
+            <a:schemeClr val="accent1"/>
           </a:solidFill>
           <a:ln/>
         </p:spPr>
       </p:sp>
       <p:sp>
         <p:nvSpPr>
-          <p:cNvPr id="29" name="Text 27"/>
-          <p:cNvSpPr txBox="1"/>
-          <p:nvPr/>
-        </p:nvSpPr>
-        <p:spPr>
-          <a:xfrm>
-            <a:off x="10899648" y="2039112"/>
-            <a:ext cx="1170432" cy="1014984"/>
+          <p:cNvPr id="44" name="Text 42"/>
+          <p:cNvSpPr txBox="1"/>
+          <p:nvPr/>
+        </p:nvSpPr>
+        <p:spPr>
+          <a:xfrm>
+            <a:off x="6291072" y="5321808"/>
+            <a:ext cx="2377440" cy="685800"/>
           </a:xfrm>
           <a:prstGeom prst="rect">
             <a:avLst/>
@@ -16383,162 +16910,25 @@
               <a:buNone/>
             </a:pPr>
             <a:r>
+              <a:rPr lang="en-US" sz="1250" b="1" dirty="0">
+                <a:solidFill>
+                  <a:schemeClr val="tx2"/>
+                </a:solidFill>
+              </a:rPr>
+              <a:t>Servicio: </a:t>
+            </a:r>
+            <a:pPr indent="0" marL="0">
+              <a:buNone/>
+            </a:pPr>
+            <a:r>
               <a:rPr lang="en-US" sz="1250" dirty="0">
                 <a:solidFill>
                   <a:schemeClr val="tx1"/>
                 </a:solidFill>
               </a:rPr>
-              <a:t>Dos flujos reales entran al mismo Kafka</a:t>
+              <a:t>ambas vistas en un solo tablero</a:t>
             </a:r>
             <a:endParaRPr lang="en-US" sz="1250" dirty="0"/>
-          </a:p>
-        </p:txBody>
-      </p:sp>
-      <p:sp>
-        <p:nvSpPr>
-          <p:cNvPr id="30" name="Shape 28"/>
-          <p:cNvSpPr/>
-          <p:nvPr/>
-        </p:nvSpPr>
-        <p:spPr>
-          <a:xfrm>
-            <a:off x="10607040" y="3154680"/>
-            <a:ext cx="146304" cy="146304"/>
-          </a:xfrm>
-          <a:prstGeom prst="ellipse">
-            <a:avLst/>
-          </a:prstGeom>
-          <a:solidFill>
-            <a:schemeClr val="accent2"/>
-          </a:solidFill>
-          <a:ln/>
-        </p:spPr>
-      </p:sp>
-      <p:sp>
-        <p:nvSpPr>
-          <p:cNvPr id="31" name="Text 29"/>
-          <p:cNvSpPr txBox="1"/>
-          <p:nvPr/>
-        </p:nvSpPr>
-        <p:spPr>
-          <a:xfrm>
-            <a:off x="10899648" y="3090672"/>
-            <a:ext cx="1170432" cy="1014984"/>
-          </a:xfrm>
-          <a:prstGeom prst="rect">
-            <a:avLst/>
-          </a:prstGeom>
-          <a:noFill/>
-          <a:ln/>
-        </p:spPr>
-        <p:txBody>
-          <a:bodyPr wrap="square" lIns="0" tIns="0" rIns="0" bIns="0" rtlCol="0" anchor="t"/>
-          <a:lstStyle/>
-          <a:p>
-            <a:pPr indent="0" marL="0">
-              <a:buNone/>
-            </a:pPr>
-            <a:r>
-              <a:rPr lang="en-US" sz="1250" dirty="0">
-                <a:solidFill>
-                  <a:schemeClr val="tx1"/>
-                </a:solidFill>
-              </a:rPr>
-              <a:t>Spark procesa y guarda en PostgreSQL</a:t>
-            </a:r>
-            <a:endParaRPr lang="en-US" sz="1250" dirty="0"/>
-          </a:p>
-        </p:txBody>
-      </p:sp>
-      <p:sp>
-        <p:nvSpPr>
-          <p:cNvPr id="32" name="Shape 30"/>
-          <p:cNvSpPr/>
-          <p:nvPr/>
-        </p:nvSpPr>
-        <p:spPr>
-          <a:xfrm>
-            <a:off x="10607040" y="4206240"/>
-            <a:ext cx="146304" cy="146304"/>
-          </a:xfrm>
-          <a:prstGeom prst="ellipse">
-            <a:avLst/>
-          </a:prstGeom>
-          <a:solidFill>
-            <a:schemeClr val="accent2"/>
-          </a:solidFill>
-          <a:ln/>
-        </p:spPr>
-      </p:sp>
-      <p:sp>
-        <p:nvSpPr>
-          <p:cNvPr id="33" name="Text 31"/>
-          <p:cNvSpPr txBox="1"/>
-          <p:nvPr/>
-        </p:nvSpPr>
-        <p:spPr>
-          <a:xfrm>
-            <a:off x="10899648" y="4142232"/>
-            <a:ext cx="1170432" cy="1014984"/>
-          </a:xfrm>
-          <a:prstGeom prst="rect">
-            <a:avLst/>
-          </a:prstGeom>
-          <a:noFill/>
-          <a:ln/>
-        </p:spPr>
-        <p:txBody>
-          <a:bodyPr wrap="square" lIns="0" tIns="0" rIns="0" bIns="0" rtlCol="0" anchor="t"/>
-          <a:lstStyle/>
-          <a:p>
-            <a:pPr indent="0" marL="0">
-              <a:buNone/>
-            </a:pPr>
-            <a:r>
-              <a:rPr lang="en-US" sz="1250" dirty="0">
-                <a:solidFill>
-                  <a:schemeClr val="tx1"/>
-                </a:solidFill>
-              </a:rPr>
-              <a:t>Prometheus vigila; Grafana lo muestra todo</a:t>
-            </a:r>
-            <a:endParaRPr lang="en-US" sz="1250" dirty="0"/>
-          </a:p>
-        </p:txBody>
-      </p:sp>
-      <p:sp>
-        <p:nvSpPr>
-          <p:cNvPr id="34" name="Text 32"/>
-          <p:cNvSpPr txBox="1"/>
-          <p:nvPr/>
-        </p:nvSpPr>
-        <p:spPr>
-          <a:xfrm>
-            <a:off x="548640" y="5943600"/>
-            <a:ext cx="8229600" cy="274320"/>
-          </a:xfrm>
-          <a:prstGeom prst="rect">
-            <a:avLst/>
-          </a:prstGeom>
-          <a:noFill/>
-          <a:ln/>
-        </p:spPr>
-        <p:txBody>
-          <a:bodyPr wrap="square" lIns="0" tIns="0" rIns="0" bIns="0" rtlCol="0" anchor="ctr"/>
-          <a:lstStyle/>
-          <a:p>
-            <a:pPr indent="0" marL="0">
-              <a:buNone/>
-            </a:pPr>
-            <a:r>
-              <a:rPr lang="en-US" sz="1050" i="1" dirty="0">
-                <a:solidFill>
-                  <a:schemeClr val="accent6"/>
-                </a:solidFill>
-              </a:rPr>
-              <a:t>Color = responsable · Azul acero: Julmer · Verde azulado: Abdul · Ciruela: Milagros</a:t>
-            </a:r>
-            <a:endParaRPr lang="en-US" sz="1050" dirty="0"/>
           </a:p>
         </p:txBody>
       </p:sp>

</xml_diff>